<commit_message>
(fix) modificacion de presentacion
</commit_message>
<xml_diff>
--- a/frontend/src/presentacion/Resumen_Presentacion.pptx
+++ b/frontend/src/presentacion/Resumen_Presentacion.pptx
@@ -6324,7 +6324,7 @@
               <a:buNone/>
             </a:pPr>
             <a:r>
-              <a:rPr lang="en-US" sz="1400" b="1" dirty="0">
+              <a:rPr lang="en-US" sz="1400" b="1" dirty="0" err="1">
                 <a:solidFill>
                   <a:srgbClr val="CADCFC"/>
                 </a:solidFill>
@@ -6332,49 +6332,21 @@
                 <a:ea typeface="Calibri" pitchFamily="34" charset="-122"/>
                 <a:cs typeface="Calibri" pitchFamily="34" charset="-120"/>
               </a:rPr>
-              <a:t>Candidato: </a:t>
-            </a:r>
-            <a:r>
-              <a:rPr lang="en-US" sz="1400" dirty="0">
-                <a:solidFill>
-                  <a:srgbClr val="FFFFFF"/>
+              <a:t>Elaborado</a:t>
+            </a:r>
+            <a:r>
+              <a:rPr lang="en-US" sz="1400" b="1" dirty="0">
+                <a:solidFill>
+                  <a:srgbClr val="CADCFC"/>
                 </a:solidFill>
                 <a:latin typeface="Calibri" pitchFamily="34" charset="0"/>
                 <a:ea typeface="Calibri" pitchFamily="34" charset="-122"/>
                 <a:cs typeface="Calibri" pitchFamily="34" charset="-120"/>
               </a:rPr>
-              <a:t>David Rodriguez</a:t>
-            </a:r>
-            <a:endParaRPr lang="en-US" sz="1400" dirty="0"/>
-          </a:p>
-        </p:txBody>
-      </p:sp>
-      <p:sp>
-        <p:nvSpPr>
-          <p:cNvPr id="10" name="Text 8"/>
-          <p:cNvSpPr/>
-          <p:nvPr/>
-        </p:nvSpPr>
-        <p:spPr>
-          <a:xfrm>
-            <a:off x="822960" y="4709160"/>
-            <a:ext cx="5486400" cy="320040"/>
-          </a:xfrm>
-          <a:prstGeom prst="rect">
-            <a:avLst/>
-          </a:prstGeom>
-          <a:noFill/>
-          <a:ln/>
-        </p:spPr>
-        <p:txBody>
-          <a:bodyPr wrap="square" lIns="0" tIns="0" rIns="0" bIns="0" rtlCol="0" anchor="ctr"/>
-          <a:lstStyle/>
-          <a:p>
-            <a:pPr marL="0" indent="0">
-              <a:buNone/>
-            </a:pPr>
-            <a:r>
-              <a:rPr lang="en-US" sz="1400" b="1" dirty="0">
+              <a:t> </a:t>
+            </a:r>
+            <a:r>
+              <a:rPr lang="en-US" sz="1400" b="1" dirty="0" err="1">
                 <a:solidFill>
                   <a:srgbClr val="CADCFC"/>
                 </a:solidFill>
@@ -6382,18 +6354,131 @@
                 <a:ea typeface="Calibri" pitchFamily="34" charset="-122"/>
                 <a:cs typeface="Calibri" pitchFamily="34" charset="-120"/>
               </a:rPr>
-              <a:t>Postulación: </a:t>
-            </a:r>
-            <a:r>
-              <a:rPr lang="en-US" sz="1400" dirty="0">
-                <a:solidFill>
-                  <a:srgbClr val="FFFFFF"/>
+              <a:t>por</a:t>
+            </a:r>
+            <a:r>
+              <a:rPr lang="en-US" sz="1400" b="1" dirty="0">
+                <a:solidFill>
+                  <a:srgbClr val="CADCFC"/>
                 </a:solidFill>
                 <a:latin typeface="Calibri" pitchFamily="34" charset="0"/>
                 <a:ea typeface="Calibri" pitchFamily="34" charset="-122"/>
                 <a:cs typeface="Calibri" pitchFamily="34" charset="-120"/>
               </a:rPr>
-              <a:t>Data Scientist Jr.</a:t>
+              <a:t>: </a:t>
+            </a:r>
+            <a:r>
+              <a:rPr lang="en-US" sz="1400" dirty="0">
+                <a:solidFill>
+                  <a:srgbClr val="FFFFFF"/>
+                </a:solidFill>
+                <a:latin typeface="Calibri" pitchFamily="34" charset="0"/>
+                <a:ea typeface="Calibri" pitchFamily="34" charset="-122"/>
+                <a:cs typeface="Calibri" pitchFamily="34" charset="-120"/>
+              </a:rPr>
+              <a:t>David Rodriguez</a:t>
+            </a:r>
+            <a:endParaRPr lang="en-US" sz="1400" dirty="0"/>
+          </a:p>
+        </p:txBody>
+      </p:sp>
+      <p:sp>
+        <p:nvSpPr>
+          <p:cNvPr id="10" name="Text 8"/>
+          <p:cNvSpPr/>
+          <p:nvPr/>
+        </p:nvSpPr>
+        <p:spPr>
+          <a:xfrm>
+            <a:off x="822960" y="4709160"/>
+            <a:ext cx="5486400" cy="320040"/>
+          </a:xfrm>
+          <a:prstGeom prst="rect">
+            <a:avLst/>
+          </a:prstGeom>
+          <a:noFill/>
+          <a:ln/>
+        </p:spPr>
+        <p:txBody>
+          <a:bodyPr wrap="square" lIns="0" tIns="0" rIns="0" bIns="0" rtlCol="0" anchor="ctr"/>
+          <a:lstStyle/>
+          <a:p>
+            <a:r>
+              <a:rPr lang="en-US" sz="1400" b="1" dirty="0" err="1">
+                <a:solidFill>
+                  <a:srgbClr val="CADCFC"/>
+                </a:solidFill>
+                <a:latin typeface="Calibri" pitchFamily="34" charset="0"/>
+                <a:ea typeface="Calibri" pitchFamily="34" charset="-122"/>
+                <a:cs typeface="Calibri" pitchFamily="34" charset="-120"/>
+              </a:rPr>
+              <a:t>Linkedin</a:t>
+            </a:r>
+            <a:r>
+              <a:rPr lang="en-US" sz="1400" b="1" dirty="0">
+                <a:solidFill>
+                  <a:srgbClr val="CADCFC"/>
+                </a:solidFill>
+                <a:latin typeface="Calibri" pitchFamily="34" charset="0"/>
+                <a:ea typeface="Calibri" pitchFamily="34" charset="-122"/>
+                <a:cs typeface="Calibri" pitchFamily="34" charset="-120"/>
+              </a:rPr>
+              <a:t>: </a:t>
+            </a:r>
+            <a:r>
+              <a:rPr lang="en-US" sz="1400" dirty="0">
+                <a:solidFill>
+                  <a:srgbClr val="FFFFFF"/>
+                </a:solidFill>
+                <a:latin typeface="Calibri" pitchFamily="34" charset="0"/>
+                <a:ea typeface="Calibri" pitchFamily="34" charset="-122"/>
+                <a:cs typeface="Calibri" pitchFamily="34" charset="-120"/>
+              </a:rPr>
+              <a:t>https://</a:t>
+            </a:r>
+            <a:r>
+              <a:rPr lang="en-US" sz="1400" dirty="0" err="1">
+                <a:solidFill>
+                  <a:srgbClr val="FFFFFF"/>
+                </a:solidFill>
+                <a:latin typeface="Calibri" pitchFamily="34" charset="0"/>
+                <a:ea typeface="Calibri" pitchFamily="34" charset="-122"/>
+                <a:cs typeface="Calibri" pitchFamily="34" charset="-120"/>
+              </a:rPr>
+              <a:t>www.linkedin.com</a:t>
+            </a:r>
+            <a:r>
+              <a:rPr lang="en-US" sz="1400" dirty="0">
+                <a:solidFill>
+                  <a:srgbClr val="FFFFFF"/>
+                </a:solidFill>
+                <a:latin typeface="Calibri" pitchFamily="34" charset="0"/>
+                <a:ea typeface="Calibri" pitchFamily="34" charset="-122"/>
+                <a:cs typeface="Calibri" pitchFamily="34" charset="-120"/>
+              </a:rPr>
+              <a:t>/in/</a:t>
+            </a:r>
+            <a:r>
+              <a:rPr lang="en-US" sz="1400" dirty="0" err="1">
+                <a:solidFill>
+                  <a:srgbClr val="FFFFFF"/>
+                </a:solidFill>
+                <a:latin typeface="Calibri" pitchFamily="34" charset="0"/>
+                <a:ea typeface="Calibri" pitchFamily="34" charset="-122"/>
+                <a:cs typeface="Calibri" pitchFamily="34" charset="-120"/>
+              </a:rPr>
+              <a:t>joeldavidrodriguez</a:t>
+            </a:r>
+            <a:r>
+              <a:rPr lang="en-US" sz="1400" dirty="0">
+                <a:solidFill>
+                  <a:srgbClr val="FFFFFF"/>
+                </a:solidFill>
+                <a:latin typeface="Calibri" pitchFamily="34" charset="0"/>
+                <a:ea typeface="Calibri" pitchFamily="34" charset="-122"/>
+                <a:cs typeface="Calibri" pitchFamily="34" charset="-120"/>
+              </a:rPr>
+              <a:t>/</a:t>
             </a:r>
             <a:endParaRPr lang="en-US" sz="1400" dirty="0"/>
           </a:p>

</xml_diff>